<commit_message>
Finalize semifinal judge evidence package
</commit_message>
<xml_diff>
--- a/submission/EgoAgentOS_GOAI_Agent_Infra_复赛方案.pptx
+++ b/submission/EgoAgentOS_GOAI_Agent_Infra_复赛方案.pptx
@@ -2,29 +2,29 @@
 <file path=ppt/presentation.xml><?xml version="1.0" encoding="utf-8"?>
 <p:presentation xmlns:p="http://schemas.openxmlformats.org/presentationml/2006/main">
   <p:sldMasterIdLst>
-    <p:sldMasterId xmlns:r="http://schemas.openxmlformats.org/officeDocument/2006/relationships" id="2147483648" r:id="R7e36fe6ed0294a2e"/>
-    <p:sldMasterId xmlns:r="http://schemas.openxmlformats.org/officeDocument/2006/relationships" id="2147483650" r:id="R586a4a8622b64173"/>
+    <p:sldMasterId xmlns:r="http://schemas.openxmlformats.org/officeDocument/2006/relationships" id="2147483648" r:id="Rc5efb17edb724d90"/>
+    <p:sldMasterId xmlns:r="http://schemas.openxmlformats.org/officeDocument/2006/relationships" id="2147483650" r:id="R7af7a5158a4d499e"/>
   </p:sldMasterIdLst>
   <p:notesMasterIdLst>
-    <p:notesMasterId xmlns:r="http://schemas.openxmlformats.org/officeDocument/2006/relationships" r:id="Re7446dbe7672497b"/>
+    <p:notesMasterId xmlns:r="http://schemas.openxmlformats.org/officeDocument/2006/relationships" r:id="R708a022b1c48411b"/>
   </p:notesMasterIdLst>
   <p:sldIdLst>
-    <p:sldId xmlns:r="http://schemas.openxmlformats.org/officeDocument/2006/relationships" id="256" r:id="Ra325631176e74b3d"/>
-    <p:sldId xmlns:r="http://schemas.openxmlformats.org/officeDocument/2006/relationships" id="257" r:id="R1ec8cfca3bf04b0f"/>
-    <p:sldId xmlns:r="http://schemas.openxmlformats.org/officeDocument/2006/relationships" id="258" r:id="R5386dccd433b4c8b"/>
-    <p:sldId xmlns:r="http://schemas.openxmlformats.org/officeDocument/2006/relationships" id="259" r:id="R500292f703134049"/>
-    <p:sldId xmlns:r="http://schemas.openxmlformats.org/officeDocument/2006/relationships" id="260" r:id="Rdde12a1d84ac42cb"/>
-    <p:sldId xmlns:r="http://schemas.openxmlformats.org/officeDocument/2006/relationships" id="261" r:id="Ref4b455fe34b46d7"/>
-    <p:sldId xmlns:r="http://schemas.openxmlformats.org/officeDocument/2006/relationships" id="262" r:id="R7b15c1edc0904f2b"/>
-    <p:sldId xmlns:r="http://schemas.openxmlformats.org/officeDocument/2006/relationships" id="263" r:id="R3345b5c7257b41e2"/>
-    <p:sldId xmlns:r="http://schemas.openxmlformats.org/officeDocument/2006/relationships" id="264" r:id="R1c3e690d83da41e9"/>
-    <p:sldId xmlns:r="http://schemas.openxmlformats.org/officeDocument/2006/relationships" id="265" r:id="R210ea9e597e643a1"/>
-    <p:sldId xmlns:r="http://schemas.openxmlformats.org/officeDocument/2006/relationships" id="266" r:id="R2ad00e5b425c49f5"/>
-    <p:sldId xmlns:r="http://schemas.openxmlformats.org/officeDocument/2006/relationships" id="267" r:id="Ra89516dc574a4bb1"/>
-    <p:sldId xmlns:r="http://schemas.openxmlformats.org/officeDocument/2006/relationships" id="268" r:id="R75affd60c910487c"/>
-    <p:sldId xmlns:r="http://schemas.openxmlformats.org/officeDocument/2006/relationships" id="269" r:id="R26bb4f51457945a0"/>
-    <p:sldId xmlns:r="http://schemas.openxmlformats.org/officeDocument/2006/relationships" id="270" r:id="Rb4a22c39614143f4"/>
-    <p:sldId xmlns:r="http://schemas.openxmlformats.org/officeDocument/2006/relationships" id="271" r:id="R38d6fa0b20ee46c4"/>
+    <p:sldId xmlns:r="http://schemas.openxmlformats.org/officeDocument/2006/relationships" id="256" r:id="Rf4f2fd7dcc954405"/>
+    <p:sldId xmlns:r="http://schemas.openxmlformats.org/officeDocument/2006/relationships" id="257" r:id="Rd354fb019a684c27"/>
+    <p:sldId xmlns:r="http://schemas.openxmlformats.org/officeDocument/2006/relationships" id="258" r:id="Rb97074b1ad064052"/>
+    <p:sldId xmlns:r="http://schemas.openxmlformats.org/officeDocument/2006/relationships" id="259" r:id="R855d94fc46cb44e5"/>
+    <p:sldId xmlns:r="http://schemas.openxmlformats.org/officeDocument/2006/relationships" id="260" r:id="R09e2328a509d4def"/>
+    <p:sldId xmlns:r="http://schemas.openxmlformats.org/officeDocument/2006/relationships" id="261" r:id="R1cfc8e53d7e64fd6"/>
+    <p:sldId xmlns:r="http://schemas.openxmlformats.org/officeDocument/2006/relationships" id="262" r:id="Rec6ca68bf9cf4570"/>
+    <p:sldId xmlns:r="http://schemas.openxmlformats.org/officeDocument/2006/relationships" id="263" r:id="R74c25b312bd4431e"/>
+    <p:sldId xmlns:r="http://schemas.openxmlformats.org/officeDocument/2006/relationships" id="264" r:id="Rdf0d5f2cb1be4347"/>
+    <p:sldId xmlns:r="http://schemas.openxmlformats.org/officeDocument/2006/relationships" id="265" r:id="R89225a08052f404c"/>
+    <p:sldId xmlns:r="http://schemas.openxmlformats.org/officeDocument/2006/relationships" id="266" r:id="R8e9db65061f84940"/>
+    <p:sldId xmlns:r="http://schemas.openxmlformats.org/officeDocument/2006/relationships" id="267" r:id="R8034afb4d54f4978"/>
+    <p:sldId xmlns:r="http://schemas.openxmlformats.org/officeDocument/2006/relationships" id="268" r:id="Rf72241a24cbb4679"/>
+    <p:sldId xmlns:r="http://schemas.openxmlformats.org/officeDocument/2006/relationships" id="269" r:id="R3a60c743ac90408b"/>
+    <p:sldId xmlns:r="http://schemas.openxmlformats.org/officeDocument/2006/relationships" id="270" r:id="Rb83cf63624aa43ba"/>
+    <p:sldId xmlns:r="http://schemas.openxmlformats.org/officeDocument/2006/relationships" id="271" r:id="Raf3b8904c7c84ec4"/>
   </p:sldIdLst>
   <p:sldSz cx="12192000" cy="6858000"/>
   <p:notesSz cx="6858000" cy="9144000"/>
@@ -769,12 +769,17 @@
           </a:p>
           <a:p xmlns:a="http://schemas.openxmlformats.org/drawingml/2006/main">
             <a:r>
+              <a:t>- docs/evidence/postgres-local-proof-2026-08-29.md</a:t>
+            </a:r>
+          </a:p>
+          <a:p xmlns:a="http://schemas.openxmlformats.org/drawingml/2006/main">
+            <a:r>
               <a:t>- benchmarks/artifacts/</a:t>
             </a:r>
           </a:p>
           <a:p xmlns:a="http://schemas.openxmlformats.org/drawingml/2006/main">
             <a:r>
-              <a:t>- .github/workflows/ci.yml</a:t>
+              <a:t>- semifinal_acceptance/README.md</a:t>
             </a:r>
           </a:p>
           <a:p xmlns:a="http://schemas.openxmlformats.org/drawingml/2006/main">
@@ -789,7 +794,7 @@
           </a:p>
           <a:p xmlns:a="http://schemas.openxmlformats.org/drawingml/2006/main">
             <a:r>
-              <a:t>35 秒：只读最终 verification report 的本轮数字，live target 仍单列 SKIP。</a:t>
+              <a:t>35 秒：默认 209 与独立 PG 27 分开计数；任何 official AgentTeams、GPU 或 PolarDB live 结论都不从本地测试外推。</a:t>
             </a:r>
           </a:p>
         </p:txBody>
@@ -969,7 +974,12 @@
           </a:p>
           <a:p xmlns:a="http://schemas.openxmlformats.org/drawingml/2006/main">
             <a:r>
-              <a:t>- tests/postgres/</a:t>
+              <a:t>- apps/api/polardb_preflight.py</a:t>
+            </a:r>
+          </a:p>
+          <a:p xmlns:a="http://schemas.openxmlformats.org/drawingml/2006/main">
+            <a:r>
+              <a:t>- deploy/postgres/security_roles.sql</a:t>
             </a:r>
           </a:p>
           <a:p xmlns:a="http://schemas.openxmlformats.org/drawingml/2006/main">
@@ -979,6 +989,11 @@
           </a:p>
           <a:p xmlns:a="http://schemas.openxmlformats.org/drawingml/2006/main">
             <a:r>
+              <a:t>- docs/polardb-live-acceptance-runbook.md</a:t>
+            </a:r>
+          </a:p>
+          <a:p xmlns:a="http://schemas.openxmlformats.org/drawingml/2006/main">
+            <a:r>
               <a:t/>
             </a:r>
           </a:p>
@@ -989,7 +1004,7 @@
           </a:p>
           <a:p xmlns:a="http://schemas.openxmlformats.org/drawingml/2006/main">
             <a:r>
-              <a:t>30 秒：展示 Docker PostgreSQL proof；明确 PolarDB / PITR 未跑。</a:t>
+              <a:t>30 秒：本地 PostgreSQL 16.14 已验证 27 项；PolarDB、PITR、读写分离和 failover 只能由云端报告升级状态。</a:t>
             </a:r>
           </a:p>
         </p:txBody>
@@ -1069,16 +1084,21 @@
           </a:p>
           <a:p xmlns:a="http://schemas.openxmlformats.org/drawingml/2006/main">
             <a:r>
+              <a:t>- docs/judge-feedback-implementation.md</a:t>
+            </a:r>
+          </a:p>
+          <a:p xmlns:a="http://schemas.openxmlformats.org/drawingml/2006/main">
+            <a:r>
+              <a:t>- semifinal_acceptance/README.md</a:t>
+            </a:r>
+          </a:p>
+          <a:p xmlns:a="http://schemas.openxmlformats.org/drawingml/2006/main">
+            <a:r>
               <a:t>- submission/semifinal-evidence-index.md</a:t>
             </a:r>
           </a:p>
           <a:p xmlns:a="http://schemas.openxmlformats.org/drawingml/2006/main">
             <a:r>
-              <a:t>- LICENSE</a:t>
-            </a:r>
-          </a:p>
-          <a:p xmlns:a="http://schemas.openxmlformats.org/drawingml/2006/main">
-            <a:r>
               <a:t/>
             </a:r>
           </a:p>
@@ -1089,7 +1109,7 @@
           </a:p>
           <a:p xmlns:a="http://schemas.openxmlformats.org/drawingml/2006/main">
             <a:r>
-              <a:t>25 秒：解释 claim ledger；GitHub Pages 只证明静态演示。</a:t>
+              <a:t>25 秒：把已运行、合同已验证与外部 NOT RUN 分层；一键包也不会把 operator assertion 冒充可认证 origin。</a:t>
             </a:r>
           </a:p>
         </p:txBody>
@@ -1164,7 +1184,17 @@
           </a:p>
           <a:p xmlns:a="http://schemas.openxmlformats.org/drawingml/2006/main">
             <a:r>
-              <a:t>- docs/demo-runbook.md</a:t>
+              <a:t>- docs/judge-feedback-implementation.md</a:t>
+            </a:r>
+          </a:p>
+          <a:p xmlns:a="http://schemas.openxmlformats.org/drawingml/2006/main">
+            <a:r>
+              <a:t>- docs/agentteams-live-runbook.md</a:t>
+            </a:r>
+          </a:p>
+          <a:p xmlns:a="http://schemas.openxmlformats.org/drawingml/2006/main">
+            <a:r>
+              <a:t>- docs/polardb-live-acceptance-runbook.md</a:t>
             </a:r>
           </a:p>
           <a:p xmlns:a="http://schemas.openxmlformats.org/drawingml/2006/main">
@@ -1174,11 +1204,6 @@
           </a:p>
           <a:p xmlns:a="http://schemas.openxmlformats.org/drawingml/2006/main">
             <a:r>
-              <a:t>- Makefile</a:t>
-            </a:r>
-          </a:p>
-          <a:p xmlns:a="http://schemas.openxmlformats.org/drawingml/2006/main">
-            <a:r>
               <a:t/>
             </a:r>
           </a:p>
@@ -1189,7 +1214,7 @@
           </a:p>
           <a:p xmlns:a="http://schemas.openxmlformats.org/drawingml/2006/main">
             <a:r>
-              <a:t>20 秒：给出四段复现路径和最终一句话。</a:t>
+              <a:t>20 秒：先复现本地合同，再说明 live acceptance 需要同一 run 的官方协作、GPU、数据库与恢复证据。</a:t>
             </a:r>
           </a:p>
         </p:txBody>
@@ -1264,12 +1289,12 @@
           </a:p>
           <a:p xmlns:a="http://schemas.openxmlformats.org/drawingml/2006/main">
             <a:r>
-              <a:t>- GOAI semifinal rules</a:t>
-            </a:r>
-          </a:p>
-          <a:p xmlns:a="http://schemas.openxmlformats.org/drawingml/2006/main">
-            <a:r>
-              <a:t>- GOAI optimization feedback email</a:t>
+              <a:t>- User-provided semifinal judge feedback</a:t>
+            </a:r>
+          </a:p>
+          <a:p xmlns:a="http://schemas.openxmlformats.org/drawingml/2006/main">
+            <a:r>
+              <a:t>- docs/judge-feedback-implementation.md</a:t>
             </a:r>
           </a:p>
           <a:p xmlns:a="http://schemas.openxmlformats.org/drawingml/2006/main">
@@ -1289,7 +1314,7 @@
           </a:p>
           <a:p xmlns:a="http://schemas.openxmlformats.org/drawingml/2006/main">
             <a:r>
-              <a:t>35 秒：逐项对齐初赛反馈。红色条目就是本轮实改；SKIP 是门禁，不是遮掩。</a:t>
+              <a:t>35 秒：两条评委意见都已落成代码与本地证据；外部 live 项仍明确标记 NOT RUN / UNVERIFIED。</a:t>
             </a:r>
           </a:p>
         </p:txBody>
@@ -1464,12 +1489,17 @@
           </a:p>
           <a:p xmlns:a="http://schemas.openxmlformats.org/drawingml/2006/main">
             <a:r>
+              <a:t>- docs/judge-feedback-implementation.md</a:t>
+            </a:r>
+          </a:p>
+          <a:p xmlns:a="http://schemas.openxmlformats.org/drawingml/2006/main">
+            <a:r>
               <a:t>- integrations/agentteams/README.md</a:t>
             </a:r>
           </a:p>
           <a:p xmlns:a="http://schemas.openxmlformats.org/drawingml/2006/main">
             <a:r>
-              <a:t>- skill_runtime/registry.py</a:t>
+              <a:t>- apps/agentteams_bridge/postgres_store.py</a:t>
             </a:r>
           </a:p>
           <a:p xmlns:a="http://schemas.openxmlformats.org/drawingml/2006/main">
@@ -1484,7 +1514,7 @@
           </a:p>
           <a:p xmlns:a="http://schemas.openxmlformats.org/drawingml/2006/main">
             <a:r>
-              <a:t>35 秒：三平面各司其职；唯一事实链由同一 run_id 贯穿。</a:t>
+              <a:t>35 秒：协作、实验事实与受控动作共用同一 run_id；PostgreSQL 是 production path，SQLite 只保留 dev fallback。</a:t>
             </a:r>
           </a:p>
         </p:txBody>
@@ -1659,21 +1689,26 @@
           </a:p>
           <a:p xmlns:a="http://schemas.openxmlformats.org/drawingml/2006/main">
             <a:r>
-              <a:t>- integrations/agentteams/</a:t>
-            </a:r>
-          </a:p>
-          <a:p xmlns:a="http://schemas.openxmlformats.org/drawingml/2006/main">
-            <a:r>
               <a:t>- apps/agentteams_bridge/</a:t>
             </a:r>
           </a:p>
           <a:p xmlns:a="http://schemas.openxmlformats.org/drawingml/2006/main">
             <a:r>
+              <a:t>- integrations/agentteams/benchmark_adapter.py</a:t>
+            </a:r>
+          </a:p>
+          <a:p xmlns:a="http://schemas.openxmlformats.org/drawingml/2006/main">
+            <a:r>
               <a:t>- tests/agentteams/</a:t>
             </a:r>
           </a:p>
           <a:p xmlns:a="http://schemas.openxmlformats.org/drawingml/2006/main">
             <a:r>
+              <a:t>- docs/agentteams-live-runbook.md</a:t>
+            </a:r>
+          </a:p>
+          <a:p xmlns:a="http://schemas.openxmlformats.org/drawingml/2006/main">
+            <a:r>
               <a:t/>
             </a:r>
           </a:p>
@@ -1684,7 +1719,7 @@
           </a:p>
           <a:p xmlns:a="http://schemas.openxmlformats.org/drawingml/2006/main">
             <a:r>
-              <a:t>40 秒：从正常协作转到 conflict / timeout / reassign；live service 没配就展示 SKIP。</a:t>
+              <a:t>40 秒：展示 PostgreSQL-backed checkpoint、完整 trace 验链与 crash/reassign；没有官方来源证明就不会升级为 live。</a:t>
             </a:r>
           </a:p>
         </p:txBody>
@@ -2079,7 +2114,7 @@
   </p:cSld>
   <p:clrMap bg1="lt1" tx1="dk1" bg2="lt2" tx2="dk2" accent1="accent1" accent2="accent2" accent3="accent3" accent4="accent4" accent5="accent5" accent6="accent6" hlink="hlink" folHlink="folHlink"/>
   <p:sldLayoutIdLst>
-    <p:sldLayoutId xmlns:r="http://schemas.openxmlformats.org/officeDocument/2006/relationships" id="2147483649" r:id="R01ed88849a5c4521"/>
+    <p:sldLayoutId xmlns:r="http://schemas.openxmlformats.org/officeDocument/2006/relationships" id="2147483649" r:id="R7dcbf26137d341b3"/>
   </p:sldLayoutIdLst>
   <p:hf sldNum="0" hdr="0" ftr="0" dt="0"/>
   <p:txStyles>
@@ -2323,7 +2358,7 @@
   </p:cSld>
   <p:clrMap bg1="lt1" tx1="dk1" bg2="lt2" tx2="dk2" accent1="accent1" accent2="accent2" accent3="accent3" accent4="accent4" accent5="accent5" accent6="accent6" hlink="hlink" folHlink="folHlink"/>
   <p:sldLayoutIdLst>
-    <p:sldLayoutId xmlns:r="http://schemas.openxmlformats.org/officeDocument/2006/relationships" id="2147483651" r:id="R94016c2df2124fb9"/>
+    <p:sldLayoutId xmlns:r="http://schemas.openxmlformats.org/officeDocument/2006/relationships" id="2147483651" r:id="R0f2806edff0f4a9a"/>
   </p:sldLayoutIdLst>
   <p:hf sldNum="0" hdr="0" ftr="0" dt="0"/>
   <p:txStyles>
@@ -3441,7 +3476,7 @@
           <p:nvPr/>
         </p:nvPicPr>
         <p:blipFill>
-          <a:blip xmlns:r="http://schemas.openxmlformats.org/officeDocument/2006/relationships" xmlns:a="http://schemas.openxmlformats.org/drawingml/2006/main" r:embed="R6bd352e2a83e4faf"/>
+          <a:blip xmlns:r="http://schemas.openxmlformats.org/officeDocument/2006/relationships" xmlns:a="http://schemas.openxmlformats.org/drawingml/2006/main" r:embed="R8dd2c194b96a4080"/>
           <a:srcRect xmlns:a="http://schemas.openxmlformats.org/drawingml/2006/main" l="2642" t="0" r="2642" b="0"/>
           <a:stretch xmlns:a="http://schemas.openxmlformats.org/drawingml/2006/main">
             <a:fillRect l="0" t="0" r="0" b="0"/>
@@ -3860,7 +3895,7 @@
           <p:nvPr/>
         </p:nvPicPr>
         <p:blipFill>
-          <a:blip xmlns:r="http://schemas.openxmlformats.org/officeDocument/2006/relationships" xmlns:a="http://schemas.openxmlformats.org/drawingml/2006/main" r:embed="R7d35a6fea48c45dc"/>
+          <a:blip xmlns:r="http://schemas.openxmlformats.org/officeDocument/2006/relationships" xmlns:a="http://schemas.openxmlformats.org/drawingml/2006/main" r:embed="R84dfc0cb39d24bce"/>
           <a:srcRect xmlns:a="http://schemas.openxmlformats.org/drawingml/2006/main" l="7355" t="0" r="7355" b="0"/>
           <a:stretch xmlns:a="http://schemas.openxmlformats.org/drawingml/2006/main">
             <a:fillRect l="0" t="0" r="0" b="0"/>
@@ -3885,7 +3920,7 @@
           <p:nvPr/>
         </p:nvPicPr>
         <p:blipFill>
-          <a:blip xmlns:r="http://schemas.openxmlformats.org/officeDocument/2006/relationships" xmlns:a="http://schemas.openxmlformats.org/drawingml/2006/main" r:embed="R8bc84b21a8ac43e3"/>
+          <a:blip xmlns:r="http://schemas.openxmlformats.org/officeDocument/2006/relationships" xmlns:a="http://schemas.openxmlformats.org/drawingml/2006/main" r:embed="R079f5e3955614a1d"/>
           <a:stretch xmlns:a="http://schemas.openxmlformats.org/drawingml/2006/main"/>
         </p:blipFill>
         <p:spPr>
@@ -4301,7 +4336,7 @@
           <p:nvPr/>
         </p:nvPicPr>
         <p:blipFill>
-          <a:blip xmlns:r="http://schemas.openxmlformats.org/officeDocument/2006/relationships" xmlns:a="http://schemas.openxmlformats.org/drawingml/2006/main" r:embed="R7dce5f16d1554547"/>
+          <a:blip xmlns:r="http://schemas.openxmlformats.org/officeDocument/2006/relationships" xmlns:a="http://schemas.openxmlformats.org/drawingml/2006/main" r:embed="Re71df22514cb43d4"/>
           <a:srcRect xmlns:a="http://schemas.openxmlformats.org/drawingml/2006/main" l="7355" t="0" r="7355" b="0"/>
           <a:stretch xmlns:a="http://schemas.openxmlformats.org/drawingml/2006/main">
             <a:fillRect l="0" t="0" r="0" b="0"/>
@@ -4326,7 +4361,7 @@
           <p:nvPr/>
         </p:nvPicPr>
         <p:blipFill>
-          <a:blip xmlns:r="http://schemas.openxmlformats.org/officeDocument/2006/relationships" xmlns:a="http://schemas.openxmlformats.org/drawingml/2006/main" r:embed="Rb0edf4c3fe2943b9"/>
+          <a:blip xmlns:r="http://schemas.openxmlformats.org/officeDocument/2006/relationships" xmlns:a="http://schemas.openxmlformats.org/drawingml/2006/main" r:embed="R7b39676bdc0a4f94"/>
           <a:stretch xmlns:a="http://schemas.openxmlformats.org/drawingml/2006/main"/>
         </p:blipFill>
         <p:spPr>
@@ -4537,7 +4572,7 @@
                 <a:ea typeface="Noto Sans CJK SC"/>
                 <a:cs typeface="Noto Sans CJK SC"/>
               </a:rPr>
-              <a:t>计数以最终验证报告为准；workload 仍为 SYNTHETIC，平台实连项单列 SKIP。</a:t>
+              <a:t>默认 209 tests 全过；另有 PostgreSQL 16.14 / 27 tests。外部 live 项单列 NOT RUN。</a:t>
             </a:r>
             <a:endParaRPr sz="885" b="1">
               <a:solidFill>
@@ -5294,7 +5329,7 @@
                 <a:ea typeface="Noto Sans CJK SC"/>
                 <a:cs typeface="Noto Sans CJK SC"/>
               </a:rPr>
-              <a:t>PASS</a:t>
+              <a:t>209</a:t>
             </a:r>
             <a:endParaRPr sz="1500" b="1" i="0">
               <a:solidFill>
@@ -5359,7 +5394,7 @@
                 <a:ea typeface="Noto Sans CJK SC"/>
                 <a:cs typeface="Noto Sans CJK SC"/>
               </a:rPr>
-              <a:t>API / RXP / Skill</a:t>
+              <a:t>default suite PASS</a:t>
             </a:r>
             <a:endParaRPr sz="790" b="0" i="0">
               <a:solidFill>
@@ -5684,7 +5719,8 @@
                 <a:ea typeface="Noto Sans CJK SC"/>
                 <a:cs typeface="Noto Sans CJK SC"/>
               </a:rPr>
-              <a:t>最终全量 test count 在 evidence index 与 CI log 中冻结。</a:t>
+              <a:t>API 56 · RXP 26 · Skills 6 · Proof 1 · Benchmark 28
+Acceptance 16 · AgentTeams 28 · Experiments 13 · MCP 23 · Web 12</a:t>
             </a:r>
             <a:endParaRPr sz="720" b="0" i="0">
               <a:solidFill>
@@ -5749,7 +5785,7 @@
                 <a:ea typeface="Noto Sans CJK SC"/>
                 <a:cs typeface="Noto Sans CJK SC"/>
               </a:rPr>
-              <a:t>11</a:t>
+              <a:t>12</a:t>
             </a:r>
             <a:endParaRPr sz="1500" b="1" i="0">
               <a:solidFill>
@@ -6269,7 +6305,7 @@
                 <a:ea typeface="Noto Sans CJK SC"/>
                 <a:cs typeface="Noto Sans CJK SC"/>
               </a:rPr>
-              <a:t>1600×1000 与 390×844 已检查；RXP panel 首屏可见。</a:t>
+              <a:t>1600×1000 与 390×844 已检查；新增 semifinal acceptance path 可切换。 </a:t>
             </a:r>
             <a:endParaRPr sz="700" b="0" i="0">
               <a:solidFill>
@@ -6334,7 +6370,7 @@
                 <a:ea typeface="Noto Sans CJK SC"/>
                 <a:cs typeface="Noto Sans CJK SC"/>
               </a:rPr>
-              <a:t>LOCK</a:t>
+              <a:t>28</a:t>
             </a:r>
             <a:endParaRPr sz="1500" b="1" i="0">
               <a:solidFill>
@@ -6399,7 +6435,7 @@
                 <a:ea typeface="Noto Sans CJK SC"/>
                 <a:cs typeface="Noto Sans CJK SC"/>
               </a:rPr>
-              <a:t>official API adapter</a:t>
+              <a:t>AgentTeams tests</a:t>
             </a:r>
             <a:endParaRPr sz="790" b="0" i="0">
               <a:solidFill>
@@ -6464,7 +6500,7 @@
                 <a:ea typeface="Noto Sans CJK SC"/>
                 <a:cs typeface="Noto Sans CJK SC"/>
               </a:rPr>
-              <a:t>DOCKER</a:t>
+              <a:t>27</a:t>
             </a:r>
             <a:endParaRPr sz="1500" b="1" i="0">
               <a:solidFill>
@@ -6529,7 +6565,7 @@
                 <a:ea typeface="Noto Sans CJK SC"/>
                 <a:cs typeface="Noto Sans CJK SC"/>
               </a:rPr>
-              <a:t>Postgres proof</a:t>
+              <a:t>PostgreSQL 16.14</a:t>
             </a:r>
             <a:endParaRPr sz="790" b="0" i="0">
               <a:solidFill>
@@ -6594,7 +6630,7 @@
                 <a:ea typeface="Noto Sans CJK SC"/>
                 <a:cs typeface="Noto Sans CJK SC"/>
               </a:rPr>
-              <a:t>SKIP</a:t>
+              <a:t>NOT RUN</a:t>
             </a:r>
             <a:endParaRPr sz="1500" b="1" i="0">
               <a:solidFill>
@@ -6659,7 +6695,7 @@
                 <a:ea typeface="Noto Sans CJK SC"/>
                 <a:cs typeface="Noto Sans CJK SC"/>
               </a:rPr>
-              <a:t>live platform</a:t>
+              <a:t>external live</a:t>
             </a:r>
             <a:endParaRPr sz="790" b="0" i="0">
               <a:solidFill>
@@ -6724,7 +6760,7 @@
                 <a:ea typeface="Noto Sans CJK SC"/>
                 <a:cs typeface="Noto Sans CJK SC"/>
               </a:rPr>
-              <a:t>真实 Docker PostgreSQL 测试与官方 AgentTeams contract trace 分开陈述。</a:t>
+              <a:t>bridge/trace 与本地 PG 实库通过；official AgentTeams、GPU、PolarDB 不在此结果中。</a:t>
             </a:r>
             <a:endParaRPr sz="705" b="0" i="0">
               <a:solidFill>
@@ -7244,7 +7280,7 @@
                 <a:ea typeface="Noto Sans CJK SC"/>
                 <a:cs typeface="Noto Sans CJK SC"/>
               </a:rPr>
-              <a:t>证据命令：make test · make benchmark · rxp demo/verify · npm test/build</a:t>
+              <a:t>证据命令：make test · pytest tests/postgres · ego-semifinal-bundle verify · make package</a:t>
             </a:r>
             <a:endParaRPr sz="700" b="1" i="0">
               <a:solidFill>
@@ -10463,7 +10499,7 @@
                 <a:ea typeface="Noto Sans CJK SC"/>
                 <a:cs typeface="Noto Sans CJK SC"/>
               </a:rPr>
-              <a:t>SQLite 用于离线 judge replay；PostgreSQL 用于并发、租户、通知与不可变审计。真实 PolarDB 仍需部署证明。</a:t>
+              <a:t>SQLite 仅作 dev fallback；PostgreSQL 是生产路径，承载并发、权限、通知与不可变账本。PolarDB 仍需云端实证。</a:t>
             </a:r>
             <a:endParaRPr sz="975">
               <a:solidFill>
@@ -12873,7 +12909,7 @@
                 <a:ea typeface="Noto Sans CJK SC"/>
                 <a:cs typeface="Noto Sans CJK SC"/>
               </a:rPr>
-              <a:t>SQLite local + Docker PostgreSQL tests</a:t>
+              <a:t>PostgreSQL 16.14 · 27 integration tests</a:t>
             </a:r>
             <a:endParaRPr sz="675" b="0" i="0">
               <a:solidFill>
@@ -13011,7 +13047,7 @@
                 <a:ea typeface="Noto Sans CJK SC"/>
                 <a:cs typeface="Noto Sans CJK SC"/>
               </a:rPr>
-              <a:t>MVCC · RLS · immutable trigger · LISTEN/NOTIFY</a:t>
+              <a:t>4 roles · RLS · append-only · LISTEN/NOTIFY</a:t>
             </a:r>
             <a:endParaRPr sz="675" b="0" i="0">
               <a:solidFill>
@@ -13149,7 +13185,7 @@
                 <a:ea typeface="Noto Sans CJK SC"/>
                 <a:cs typeface="Noto Sans CJK SC"/>
               </a:rPr>
-              <a:t>PolarDB endpoint · PITR restore · cloud IAM</a:t>
+              <a:t>PolarDB · PITR · read/write split · cloud IAM</a:t>
             </a:r>
             <a:endParaRPr sz="675" b="0" i="0">
               <a:solidFill>
@@ -13287,7 +13323,7 @@
                 <a:ea typeface="Noto Sans CJK SC"/>
                 <a:cs typeface="Noto Sans CJK SC"/>
               </a:rPr>
-              <a:t>checksum migration + store contract</a:t>
+              <a:t>per-test schema · checksummed apply / verify</a:t>
             </a:r>
             <a:endParaRPr sz="675" b="0" i="0">
               <a:solidFill>
@@ -13425,7 +13461,7 @@
                 <a:ea typeface="Noto Sans CJK SC"/>
                 <a:cs typeface="Noto Sans CJK SC"/>
               </a:rPr>
-              <a:t>external unavailable → local replay</a:t>
+              <a:t>explicit SQLite dev only · PG never silent fallback</a:t>
             </a:r>
             <a:endParaRPr sz="675" b="0" i="0">
               <a:solidFill>
@@ -13563,7 +13599,7 @@
                 <a:ea typeface="Noto Sans CJK SC"/>
                 <a:cs typeface="Noto Sans CJK SC"/>
               </a:rPr>
-              <a:t>per-test schema + production backup drill</a:t>
+              <a:t>preflight PASS + restore / failover drill</a:t>
             </a:r>
             <a:endParaRPr sz="675" b="0" i="0">
               <a:solidFill>
@@ -13776,7 +13812,7 @@
                 <a:ea typeface="Noto Sans CJK SC"/>
                 <a:cs typeface="Noto Sans CJK SC"/>
               </a:rPr>
-              <a:t>每一条判断都能落到命令、文件、artifact 或明确的 SKIP</a:t>
+              <a:t>每一条判断都能落到命令、文件、artifact 或明确的 NOT RUN</a:t>
             </a:r>
             <a:endParaRPr sz="2065" b="1">
               <a:solidFill>
@@ -14449,7 +14485,7 @@
                 <a:ea typeface="Noto Sans CJK SC"/>
                 <a:cs typeface="Noto Sans CJK SC"/>
               </a:rPr>
-              <a:t>Docker PostgreSQL + official-contract adapter tests</a:t>
+              <a:t>PostgreSQL 16.14 + AgentTeams bridge contracts</a:t>
             </a:r>
             <a:endParaRPr sz="805" b="1" i="0">
               <a:solidFill>
@@ -14514,7 +14550,7 @@
                 <a:ea typeface="Noto Sans CJK SC"/>
                 <a:cs typeface="Noto Sans CJK SC"/>
               </a:rPr>
-              <a:t>每项 evidence 与 same-run digest 对齐；负测与恢复分支保留。</a:t>
+              <a:t>PG 27 + bridge 28；账本篡改、receipt 重用、崩溃恢复与来源冒充均有负测。</a:t>
             </a:r>
             <a:endParaRPr sz="655" b="0" i="0">
               <a:solidFill>
@@ -14685,7 +14721,7 @@
                 <a:ea typeface="Noto Sans CJK SC"/>
                 <a:cs typeface="Noto Sans CJK SC"/>
               </a:rPr>
-              <a:t>live AgentTeams · live GPU · PolarDB / PITR</a:t>
+              <a:t>official AgentTeams · single GPU · PolarDB / PITR</a:t>
             </a:r>
             <a:endParaRPr sz="805" b="1" i="0">
               <a:solidFill>
@@ -14750,7 +14786,7 @@
                 <a:ea typeface="Noto Sans CJK SC"/>
                 <a:cs typeface="Noto Sans CJK SC"/>
               </a:rPr>
-              <a:t>没有 credentials / endpoint / same-run trace，就不把设计写成集成成功。</a:t>
+              <a:t>没有可认证 origin、endpoint 与 same-run trace，就不把 contract 写成 live 成功。</a:t>
             </a:r>
             <a:endParaRPr sz="655" b="0" i="0">
               <a:solidFill>
@@ -14815,7 +14851,7 @@
                 <a:ea typeface="Noto Sans CJK SC"/>
                 <a:cs typeface="Noto Sans CJK SC"/>
               </a:rPr>
-              <a:t>SYNTHETIC：EgoLite workload、resource trace、model metrics；真实的是控制面、协议、测试与 UI。</a:t>
+              <a:t>SYNTHETIC：托管 EgoLite 指标；Fashion-MNIST adapter 已实现，但 live origin 仍 UNVERIFIED。</a:t>
             </a:r>
             <a:endParaRPr sz="670" b="1" i="0">
               <a:solidFill>
@@ -15481,7 +15517,7 @@
                 <a:ea typeface="Noto Sans CJK SC"/>
                 <a:cs typeface="Noto Sans CJK SC"/>
               </a:rPr>
-              <a:t>make demo-proof</a:t>
+              <a:t>demo-proof + acceptance</a:t>
             </a:r>
             <a:endParaRPr sz="765" b="1" i="0">
               <a:solidFill>
@@ -15617,7 +15653,7 @@
                 <a:ea typeface="Noto Sans CJK SC"/>
                 <a:cs typeface="Noto Sans CJK SC"/>
               </a:rPr>
-              <a:t>ledger · matrix · benchmark · claim manifest</a:t>
+              <a:t>ledger · raw metrics · Matrix · trace · Decision</a:t>
             </a:r>
             <a:endParaRPr sz="655" b="0" i="0">
               <a:solidFill>
@@ -16141,7 +16177,7 @@
                 <a:ea typeface="Noto Sans CJK SC"/>
                 <a:cs typeface="Noto Sans CJK SC"/>
               </a:rPr>
-              <a:t>operator live run</a:t>
+              <a:t>operator live bundle</a:t>
             </a:r>
             <a:endParaRPr sz="765" b="1" i="0">
               <a:solidFill>
@@ -16277,7 +16313,7 @@
                 <a:ea typeface="Noto Sans CJK SC"/>
                 <a:cs typeface="Noto Sans CJK SC"/>
               </a:rPr>
-              <a:t>注入 credentials 后保存 official trace</a:t>
+              <a:t>官方 trace + raw metrics + origin attestation</a:t>
             </a:r>
             <a:endParaRPr sz="655" b="0" i="0">
               <a:solidFill>
@@ -17473,7 +17509,7 @@
                 <a:ea typeface="Noto Sans CJK SC"/>
                 <a:cs typeface="Noto Sans CJK SC"/>
               </a:rPr>
-              <a:t>AgentTeams 创建 / 委派 / 异常重路由。</a:t>
+              <a:t>AgentTeams → 人工审批 → bounded single-GPU contract。</a:t>
             </a:r>
             <a:endParaRPr sz="655" b="0" i="0">
               <a:solidFill>
@@ -17680,7 +17716,7 @@
                 <a:ea typeface="Noto Sans CJK SC"/>
                 <a:cs typeface="Noto Sans CJK SC"/>
               </a:rPr>
-              <a:t>R2 Grant → Receipt → 2/2 Matrix closure。</a:t>
+              <a:t>raw metrics → deterministic eval → reviewer → Decision。</a:t>
             </a:r>
             <a:endParaRPr sz="655" b="0" i="0">
               <a:solidFill>
@@ -17887,7 +17923,7 @@
                 <a:ea typeface="Noto Sans CJK SC"/>
                 <a:cs typeface="Noto Sans CJK SC"/>
               </a:rPr>
-              <a:t>fault benchmark、PostgreSQL、SKIP boundary。</a:t>
+              <a:t>PG roles / recovery、benchmark 与 NOT RUN boundary。</a:t>
             </a:r>
             <a:endParaRPr sz="655" b="0" i="0">
               <a:solidFill>
@@ -18012,7 +18048,7 @@
                 <a:ea typeface="Noto Sans CJK SC"/>
                 <a:cs typeface="Noto Sans CJK SC"/>
               </a:rPr>
-              <a:t>评委复现：一个入口，四段证据</a:t>
+              <a:t>评委复现：一个入口，三步复现</a:t>
             </a:r>
             <a:endParaRPr sz="1425" b="1">
               <a:solidFill>
@@ -18290,7 +18326,7 @@
                 <a:ea typeface="Noto Sans CJK SC"/>
                 <a:cs typeface="Noto Sans CJK SC"/>
               </a:rPr>
-              <a:t>确认 STATIC FIXTURE / NO API / NO GPU 标签</a:t>
+              <a:t>确认 STATIC REPLAY / CONTRACT IMPLEMENTED / EXTERNAL NOT RUN</a:t>
             </a:r>
             <a:endParaRPr sz="675" b="0" i="0">
               <a:solidFill>
@@ -18497,7 +18533,7 @@
                 <a:ea typeface="Noto Sans CJK SC"/>
                 <a:cs typeface="Noto Sans CJK SC"/>
               </a:rPr>
-              <a:t>make test · rxp demo / verify · benchmark dev gate</a:t>
+              <a:t>make test · PostgreSQL 27 · acceptance bundle verify</a:t>
             </a:r>
             <a:endParaRPr sz="675" b="0" i="0">
               <a:solidFill>
@@ -18704,7 +18740,7 @@
                 <a:ea typeface="Noto Sans CJK SC"/>
                 <a:cs typeface="Noto Sans CJK SC"/>
               </a:rPr>
-              <a:t>无 live target 时必须失败；查看 persisted evidence bundle</a:t>
+              <a:t>无可认证 origin 时禁止 live claim；检查 frozen acceptance bundle</a:t>
             </a:r>
             <a:endParaRPr sz="675" b="0" i="0">
               <a:solidFill>
@@ -18769,7 +18805,7 @@
                 <a:ea typeface="Noto Sans CJK SC"/>
                 <a:cs typeface="Noto Sans CJK SC"/>
               </a:rPr>
-              <a:t>附包：docs/demo-runbook.md · submission/semifinal-evidence-index.md · benchmark artifacts</a:t>
+              <a:t>附包：judge-feedback-implementation.md · acceptance bundle · evidence index · benchmark artifacts</a:t>
             </a:r>
             <a:endParaRPr sz="715" b="1" i="0">
               <a:solidFill>
@@ -18921,7 +18957,7 @@
                 <a:ea typeface="Noto Sans CJK SC"/>
                 <a:cs typeface="Noto Sans CJK SC"/>
               </a:rPr>
-              <a:t>P0 · 初赛反馈闭环</a:t>
+              <a:t>P0 · 复赛评委意见闭环</a:t>
             </a:r>
             <a:endParaRPr sz="1200" b="1">
               <a:solidFill>
@@ -18979,7 +19015,7 @@
                 <a:ea typeface="Noto Sans CJK SC"/>
                 <a:cs typeface="Noto Sans CJK SC"/>
               </a:rPr>
-              <a:t>从 local synthetic 升级为 protocol + live-ready</a:t>
+              <a:t>从 local proof 升级为 protocol + production-ready</a:t>
             </a:r>
             <a:endParaRPr sz="2900" b="1">
               <a:solidFill>
@@ -19160,7 +19196,7 @@
                 <a:ea typeface="Noto Sans CJK SC"/>
                 <a:cs typeface="Noto Sans CJK SC"/>
               </a:rPr>
-              <a:t>AgentTeams bridge</a:t>
+              <a:t>AgentTeams + bounded GPU chain</a:t>
             </a:r>
             <a:endParaRPr sz="1065">
               <a:solidFill>
@@ -19221,7 +19257,7 @@
                 <a:ea typeface="Noto Sans CJK SC"/>
                 <a:cs typeface="Noto Sans CJK SC"/>
               </a:rPr>
-              <a:t>官方 API contract · live service = SKIP</a:t>
+              <a:t>bridge · recovery｜official live NOT RUN</a:t>
             </a:r>
             <a:endParaRPr sz="990" b="1" i="1">
               <a:solidFill>
@@ -19402,7 +19438,7 @@
                 <a:ea typeface="Noto Sans CJK SC"/>
                 <a:cs typeface="Noto Sans CJK SC"/>
               </a:rPr>
-              <a:t>PostgreSQL profile</a:t>
+              <a:t>PostgreSQL control plane</a:t>
             </a:r>
             <a:endParaRPr sz="1065">
               <a:solidFill>
@@ -19463,7 +19499,7 @@
                 <a:ea typeface="Noto Sans CJK SC"/>
                 <a:cs typeface="Noto Sans CJK SC"/>
               </a:rPr>
-              <a:t>MVCC · RLS · immutable · LISTEN/NOTIFY</a:t>
+              <a:t>4 roles · RLS · append-only · LISTEN/NOTIFY</a:t>
             </a:r>
             <a:endParaRPr sz="990" b="1" i="1">
               <a:solidFill>
@@ -19886,7 +19922,7 @@
                 <a:ea typeface="Noto Sans CJK SC"/>
                 <a:cs typeface="Noto Sans CJK SC"/>
               </a:rPr>
-              <a:t>14 adversarial scenarios</a:t>
+              <a:t>14 scenarios + 8 acceptance cases</a:t>
             </a:r>
             <a:endParaRPr sz="1065">
               <a:solidFill>
@@ -19947,7 +19983,7 @@
                 <a:ea typeface="Noto Sans CJK SC"/>
                 <a:cs typeface="Noto Sans CJK SC"/>
               </a:rPr>
-              <a:t>naive / core / target · independent oracle</a:t>
+              <a:t>trace oracle · origin gate · recovery assertions</a:t>
             </a:r>
             <a:endParaRPr sz="990" b="1" i="1">
               <a:solidFill>
@@ -20128,7 +20164,7 @@
                 <a:ea typeface="Noto Sans CJK SC"/>
                 <a:cs typeface="Noto Sans CJK SC"/>
               </a:rPr>
-              <a:t>Cockpit + proof bundle</a:t>
+              <a:t>Cockpit + one-click acceptance bundle</a:t>
             </a:r>
             <a:endParaRPr sz="1065">
               <a:solidFill>
@@ -20189,7 +20225,7 @@
                 <a:ea typeface="Noto Sans CJK SC"/>
                 <a:cs typeface="Noto Sans CJK SC"/>
               </a:rPr>
-              <a:t>GitHub Pages 静态真相 · local full stack</a:t>
+              <a:t>static replay · local full stack · frozen evidence</a:t>
             </a:r>
             <a:endParaRPr sz="990" b="1" i="1">
               <a:solidFill>
@@ -20370,7 +20406,7 @@
                 <a:ea typeface="Noto Sans CJK SC"/>
                 <a:cs typeface="Noto Sans CJK SC"/>
               </a:rPr>
-              <a:t>PASS / SKIP 分层</a:t>
+              <a:t>PASS / NOT RUN / UNVERIFIED</a:t>
             </a:r>
             <a:endParaRPr sz="1065">
               <a:solidFill>
@@ -20431,7 +20467,7 @@
                 <a:ea typeface="Noto Sans CJK SC"/>
                 <a:cs typeface="Noto Sans CJK SC"/>
               </a:rPr>
-              <a:t>live GPU · AgentTeams · PolarDB PITR 不冒认</a:t>
+              <a:t>official AgentTeams · GPU · PolarDB/PITR 不冒认</a:t>
             </a:r>
             <a:endParaRPr sz="990" b="1" i="1">
               <a:solidFill>
@@ -21635,7 +21671,7 @@
       </p:sp>
       <p:cxnSp>
         <p:nvCxnSpPr>
-          <p:cNvPr id="120" name="直接箭头连接符 56"/>
+          <p:cNvPr id="204" name="直接箭头连接符 56"/>
           <p:cNvCxnSpPr>
             <a:stCxn xmlns:a="http://schemas.openxmlformats.org/drawingml/2006/main" id="12" idx="3"/>
             <a:endCxn xmlns:a="http://schemas.openxmlformats.org/drawingml/2006/main" id="17" idx="1"/>
@@ -21661,7 +21697,7 @@
       </p:cxnSp>
       <p:cxnSp>
         <p:nvCxnSpPr>
-          <p:cNvPr id="121" name="直接箭头连接符 57"/>
+          <p:cNvPr id="205" name="直接箭头连接符 57"/>
           <p:cNvCxnSpPr>
             <a:stCxn xmlns:a="http://schemas.openxmlformats.org/drawingml/2006/main" id="13" idx="3"/>
             <a:endCxn xmlns:a="http://schemas.openxmlformats.org/drawingml/2006/main" id="17" idx="1"/>
@@ -21687,7 +21723,7 @@
       </p:cxnSp>
       <p:cxnSp>
         <p:nvCxnSpPr>
-          <p:cNvPr id="122" name="直接箭头连接符 58"/>
+          <p:cNvPr id="206" name="直接箭头连接符 58"/>
           <p:cNvCxnSpPr>
             <a:stCxn xmlns:a="http://schemas.openxmlformats.org/drawingml/2006/main" id="14" idx="3"/>
             <a:endCxn xmlns:a="http://schemas.openxmlformats.org/drawingml/2006/main" id="17" idx="1"/>
@@ -21713,7 +21749,7 @@
       </p:cxnSp>
       <p:cxnSp>
         <p:nvCxnSpPr>
-          <p:cNvPr id="123" name="直接箭头连接符 59"/>
+          <p:cNvPr id="207" name="直接箭头连接符 59"/>
           <p:cNvCxnSpPr>
             <a:stCxn xmlns:a="http://schemas.openxmlformats.org/drawingml/2006/main" id="15" idx="3"/>
             <a:endCxn xmlns:a="http://schemas.openxmlformats.org/drawingml/2006/main" id="17" idx="1"/>
@@ -21739,7 +21775,7 @@
       </p:cxnSp>
       <p:cxnSp>
         <p:nvCxnSpPr>
-          <p:cNvPr id="124" name="直接箭头连接符 60"/>
+          <p:cNvPr id="208" name="直接箭头连接符 60"/>
           <p:cNvCxnSpPr>
             <a:stCxn xmlns:a="http://schemas.openxmlformats.org/drawingml/2006/main" id="16" idx="3"/>
             <a:endCxn xmlns:a="http://schemas.openxmlformats.org/drawingml/2006/main" id="17" idx="1"/>
@@ -21765,7 +21801,7 @@
       </p:cxnSp>
       <p:cxnSp>
         <p:nvCxnSpPr>
-          <p:cNvPr id="125" name="直接箭头连接符 61"/>
+          <p:cNvPr id="209" name="直接箭头连接符 61"/>
           <p:cNvCxnSpPr>
             <a:stCxn xmlns:a="http://schemas.openxmlformats.org/drawingml/2006/main" id="17" idx="3"/>
             <a:endCxn xmlns:a="http://schemas.openxmlformats.org/drawingml/2006/main" id="18" idx="1"/>
@@ -23158,7 +23194,7 @@
                 <a:ea typeface="Noto Sans CJK SC"/>
                 <a:cs typeface="Noto Sans CJK SC"/>
               </a:rPr>
-              <a:t>AgentTeams 管动态协作；RXP 管实验事实；Skill / MCP 管受控动作；PostgreSQL 管持久状态。</a:t>
+              <a:t>AgentTeams 管动态协作；RXP 管实验事实；Skill / MCP 管受控动作；PostgreSQL 管生产持久状态。</a:t>
             </a:r>
             <a:endParaRPr sz="1090">
               <a:solidFill>
@@ -24273,7 +24309,7 @@
                 <a:ea typeface="Noto Sans CJK SC"/>
                 <a:cs typeface="Noto Sans CJK SC"/>
               </a:rPr>
-              <a:t>Memory</a:t>
+              <a:t>Memory candidate</a:t>
             </a:r>
             <a:endParaRPr sz="805" b="1">
               <a:solidFill>
@@ -26196,7 +26232,7 @@
       </p:sp>
       <p:cxnSp>
         <p:nvCxnSpPr>
-          <p:cNvPr id="339" name="直接箭头连接符 158"/>
+          <p:cNvPr id="579" name="直接箭头连接符 158"/>
           <p:cNvCxnSpPr>
             <a:stCxn xmlns:a="http://schemas.openxmlformats.org/drawingml/2006/main" id="41" idx="3"/>
             <a:endCxn xmlns:a="http://schemas.openxmlformats.org/drawingml/2006/main" id="47" idx="1"/>
@@ -26222,7 +26258,7 @@
       </p:cxnSp>
       <p:cxnSp>
         <p:nvCxnSpPr>
-          <p:cNvPr id="340" name="直接箭头连接符 159"/>
+          <p:cNvPr id="580" name="直接箭头连接符 159"/>
           <p:cNvCxnSpPr>
             <a:stCxn xmlns:a="http://schemas.openxmlformats.org/drawingml/2006/main" id="42" idx="3"/>
             <a:endCxn xmlns:a="http://schemas.openxmlformats.org/drawingml/2006/main" id="47" idx="1"/>
@@ -26248,7 +26284,7 @@
       </p:cxnSp>
       <p:cxnSp>
         <p:nvCxnSpPr>
-          <p:cNvPr id="341" name="直接箭头连接符 160"/>
+          <p:cNvPr id="581" name="直接箭头连接符 160"/>
           <p:cNvCxnSpPr>
             <a:stCxn xmlns:a="http://schemas.openxmlformats.org/drawingml/2006/main" id="43" idx="3"/>
             <a:endCxn xmlns:a="http://schemas.openxmlformats.org/drawingml/2006/main" id="47" idx="1"/>
@@ -26274,7 +26310,7 @@
       </p:cxnSp>
       <p:cxnSp>
         <p:nvCxnSpPr>
-          <p:cNvPr id="342" name="直接箭头连接符 161"/>
+          <p:cNvPr id="582" name="直接箭头连接符 161"/>
           <p:cNvCxnSpPr>
             <a:stCxn xmlns:a="http://schemas.openxmlformats.org/drawingml/2006/main" id="44" idx="3"/>
             <a:endCxn xmlns:a="http://schemas.openxmlformats.org/drawingml/2006/main" id="47" idx="1"/>
@@ -26300,7 +26336,7 @@
       </p:cxnSp>
       <p:cxnSp>
         <p:nvCxnSpPr>
-          <p:cNvPr id="343" name="直接箭头连接符 162"/>
+          <p:cNvPr id="583" name="直接箭头连接符 162"/>
           <p:cNvCxnSpPr>
             <a:stCxn xmlns:a="http://schemas.openxmlformats.org/drawingml/2006/main" id="45" idx="3"/>
             <a:endCxn xmlns:a="http://schemas.openxmlformats.org/drawingml/2006/main" id="47" idx="1"/>
@@ -26513,7 +26549,7 @@
                 <a:ea typeface="Noto Sans CJK SC"/>
                 <a:cs typeface="Noto Sans CJK SC"/>
               </a:rPr>
-              <a:t>PostgreSQL / SQLite</a:t>
+              <a:t>PostgreSQL primary · SQLite dev</a:t>
             </a:r>
             <a:endParaRPr sz="690" b="1">
               <a:solidFill>
@@ -26862,7 +26898,7 @@
                 <a:ea typeface="Noto Sans CJK SC"/>
                 <a:cs typeface="Noto Sans CJK SC"/>
               </a:rPr>
-              <a:t>local proof 可离线重放；target profile 无真实端点时必须 SKIP，release gate 必须失败</a:t>
+              <a:t>contract + local PG 可重放；official AgentTeams / GPU / PolarDB / PITR = NOT RUN</a:t>
             </a:r>
             <a:endParaRPr sz="775" b="0" i="0">
               <a:solidFill>
@@ -30169,7 +30205,7 @@
       </p:sp>
       <p:cxnSp>
         <p:nvCxnSpPr>
-          <p:cNvPr id="339" name="直接箭头连接符 158"/>
+          <p:cNvPr id="579" name="直接箭头连接符 158"/>
           <p:cNvCxnSpPr>
             <a:stCxn xmlns:a="http://schemas.openxmlformats.org/drawingml/2006/main" id="41" idx="3"/>
             <a:endCxn xmlns:a="http://schemas.openxmlformats.org/drawingml/2006/main" id="47" idx="1"/>
@@ -30195,7 +30231,7 @@
       </p:cxnSp>
       <p:cxnSp>
         <p:nvCxnSpPr>
-          <p:cNvPr id="340" name="直接箭头连接符 159"/>
+          <p:cNvPr id="580" name="直接箭头连接符 159"/>
           <p:cNvCxnSpPr>
             <a:stCxn xmlns:a="http://schemas.openxmlformats.org/drawingml/2006/main" id="42" idx="3"/>
             <a:endCxn xmlns:a="http://schemas.openxmlformats.org/drawingml/2006/main" id="47" idx="1"/>
@@ -30221,7 +30257,7 @@
       </p:cxnSp>
       <p:cxnSp>
         <p:nvCxnSpPr>
-          <p:cNvPr id="341" name="直接箭头连接符 160"/>
+          <p:cNvPr id="581" name="直接箭头连接符 160"/>
           <p:cNvCxnSpPr>
             <a:stCxn xmlns:a="http://schemas.openxmlformats.org/drawingml/2006/main" id="43" idx="3"/>
             <a:endCxn xmlns:a="http://schemas.openxmlformats.org/drawingml/2006/main" id="47" idx="1"/>
@@ -30247,7 +30283,7 @@
       </p:cxnSp>
       <p:cxnSp>
         <p:nvCxnSpPr>
-          <p:cNvPr id="342" name="直接箭头连接符 161"/>
+          <p:cNvPr id="582" name="直接箭头连接符 161"/>
           <p:cNvCxnSpPr>
             <a:stCxn xmlns:a="http://schemas.openxmlformats.org/drawingml/2006/main" id="44" idx="3"/>
             <a:endCxn xmlns:a="http://schemas.openxmlformats.org/drawingml/2006/main" id="47" idx="1"/>
@@ -30273,7 +30309,7 @@
       </p:cxnSp>
       <p:cxnSp>
         <p:nvCxnSpPr>
-          <p:cNvPr id="343" name="直接箭头连接符 162"/>
+          <p:cNvPr id="583" name="直接箭头连接符 162"/>
           <p:cNvCxnSpPr>
             <a:stCxn xmlns:a="http://schemas.openxmlformats.org/drawingml/2006/main" id="45" idx="3"/>
             <a:endCxn xmlns:a="http://schemas.openxmlformats.org/drawingml/2006/main" id="47" idx="1"/>
@@ -31043,7 +31079,7 @@
                 <a:ea typeface="Noto Sans CJK SC"/>
                 <a:cs typeface="Noto Sans CJK SC"/>
               </a:rPr>
-              <a:t>官方 Project API / Task / Artifact 语义通过 adapter 封装；同一 run 同时产出 AgentTeams trace 与 RXP closure refs。</a:t>
+              <a:t>Bridge 将官方响应、typed Matrix、checkpoint、receipt 与 Decision 绑定同一 run，并可持久化到 PostgreSQL。</a:t>
             </a:r>
             <a:endParaRPr sz="1065">
               <a:solidFill>
@@ -32594,7 +32630,7 @@
                 <a:ea typeface="Noto Sans CJK SC"/>
                 <a:cs typeface="Noto Sans CJK SC"/>
               </a:rPr>
-              <a:t>Memory</a:t>
+              <a:t>Memory candidate</a:t>
             </a:r>
             <a:endParaRPr sz="750" b="1" i="0">
               <a:solidFill>
@@ -32659,7 +32695,7 @@
                 <a:ea typeface="Noto Sans CJK SC"/>
                 <a:cs typeface="Noto Sans CJK SC"/>
               </a:rPr>
-              <a:t>验证后沉淀</a:t>
+              <a:t>candidate only</a:t>
             </a:r>
             <a:endParaRPr sz="675" b="0" i="0">
               <a:solidFill>
@@ -34519,7 +34555,7 @@
                 <a:ea typeface="Noto Sans CJK SC"/>
                 <a:cs typeface="Noto Sans CJK SC"/>
               </a:rPr>
-              <a:t>Trace contract：official delegation + artifact + spawn/tool result + independent review + persistent hash</a:t>
+              <a:t>Trace contract：sequence + previous_hash + event_hash + typed lifecycle + independent review</a:t>
             </a:r>
             <a:endParaRPr sz="690" b="1" i="0">
               <a:solidFill>
@@ -35334,7 +35370,7 @@
                 <a:ea typeface="Noto Sans CJK SC"/>
                 <a:cs typeface="Noto Sans CJK SC"/>
               </a:rPr>
-              <a:t>本地 contract tests 可验证；未配置官方 live endpoint 时 target scenarios = SKIP，不能自证 PASS</a:t>
+              <a:t>bridge + PostgreSQL contracts 已验证；official service / Matrix / GPU 未实跑，target 必须 SKIP</a:t>
             </a:r>
             <a:endParaRPr sz="700" b="1" i="0">
               <a:solidFill>
@@ -40712,16 +40748,7 @@
               </a:rPr>
               <a:t>Dataset</a:t>
             </a:r>
-            <a:br>
-              <a:rPr sz="790" b="1" i="0">
-                <a:solidFill>
-                  <a:srgbClr val="2563EB"/>
-                </a:solidFill>
-                <a:latin typeface="Noto Sans CJK SC"/>
-                <a:ea typeface="Noto Sans CJK SC"/>
-                <a:cs typeface="Noto Sans CJK SC"/>
-              </a:rPr>
-            </a:br>
+            <a:br/>
             <a:r>
               <a:rPr sz="790" b="1" i="0">
                 <a:solidFill>

</xml_diff>

<commit_message>
Freeze semifinal benchmark and proof evidence
</commit_message>
<xml_diff>
--- a/submission/EgoAgentOS_GOAI_Agent_Infra_复赛方案.pptx
+++ b/submission/EgoAgentOS_GOAI_Agent_Infra_复赛方案.pptx
@@ -2,29 +2,29 @@
 <file path=ppt/presentation.xml><?xml version="1.0" encoding="utf-8"?>
 <p:presentation xmlns:p="http://schemas.openxmlformats.org/presentationml/2006/main">
   <p:sldMasterIdLst>
-    <p:sldMasterId xmlns:r="http://schemas.openxmlformats.org/officeDocument/2006/relationships" id="2147483648" r:id="Rc5efb17edb724d90"/>
-    <p:sldMasterId xmlns:r="http://schemas.openxmlformats.org/officeDocument/2006/relationships" id="2147483650" r:id="R7af7a5158a4d499e"/>
+    <p:sldMasterId xmlns:r="http://schemas.openxmlformats.org/officeDocument/2006/relationships" id="2147483648" r:id="R592516c0eec84571"/>
+    <p:sldMasterId xmlns:r="http://schemas.openxmlformats.org/officeDocument/2006/relationships" id="2147483650" r:id="R11f40df2be434ca7"/>
   </p:sldMasterIdLst>
   <p:notesMasterIdLst>
-    <p:notesMasterId xmlns:r="http://schemas.openxmlformats.org/officeDocument/2006/relationships" r:id="R708a022b1c48411b"/>
+    <p:notesMasterId xmlns:r="http://schemas.openxmlformats.org/officeDocument/2006/relationships" r:id="R1bacce2076b0411b"/>
   </p:notesMasterIdLst>
   <p:sldIdLst>
-    <p:sldId xmlns:r="http://schemas.openxmlformats.org/officeDocument/2006/relationships" id="256" r:id="Rf4f2fd7dcc954405"/>
-    <p:sldId xmlns:r="http://schemas.openxmlformats.org/officeDocument/2006/relationships" id="257" r:id="Rd354fb019a684c27"/>
-    <p:sldId xmlns:r="http://schemas.openxmlformats.org/officeDocument/2006/relationships" id="258" r:id="Rb97074b1ad064052"/>
-    <p:sldId xmlns:r="http://schemas.openxmlformats.org/officeDocument/2006/relationships" id="259" r:id="R855d94fc46cb44e5"/>
-    <p:sldId xmlns:r="http://schemas.openxmlformats.org/officeDocument/2006/relationships" id="260" r:id="R09e2328a509d4def"/>
-    <p:sldId xmlns:r="http://schemas.openxmlformats.org/officeDocument/2006/relationships" id="261" r:id="R1cfc8e53d7e64fd6"/>
-    <p:sldId xmlns:r="http://schemas.openxmlformats.org/officeDocument/2006/relationships" id="262" r:id="Rec6ca68bf9cf4570"/>
-    <p:sldId xmlns:r="http://schemas.openxmlformats.org/officeDocument/2006/relationships" id="263" r:id="R74c25b312bd4431e"/>
-    <p:sldId xmlns:r="http://schemas.openxmlformats.org/officeDocument/2006/relationships" id="264" r:id="Rdf0d5f2cb1be4347"/>
-    <p:sldId xmlns:r="http://schemas.openxmlformats.org/officeDocument/2006/relationships" id="265" r:id="R89225a08052f404c"/>
-    <p:sldId xmlns:r="http://schemas.openxmlformats.org/officeDocument/2006/relationships" id="266" r:id="R8e9db65061f84940"/>
-    <p:sldId xmlns:r="http://schemas.openxmlformats.org/officeDocument/2006/relationships" id="267" r:id="R8034afb4d54f4978"/>
-    <p:sldId xmlns:r="http://schemas.openxmlformats.org/officeDocument/2006/relationships" id="268" r:id="Rf72241a24cbb4679"/>
-    <p:sldId xmlns:r="http://schemas.openxmlformats.org/officeDocument/2006/relationships" id="269" r:id="R3a60c743ac90408b"/>
-    <p:sldId xmlns:r="http://schemas.openxmlformats.org/officeDocument/2006/relationships" id="270" r:id="Rb83cf63624aa43ba"/>
-    <p:sldId xmlns:r="http://schemas.openxmlformats.org/officeDocument/2006/relationships" id="271" r:id="Raf3b8904c7c84ec4"/>
+    <p:sldId xmlns:r="http://schemas.openxmlformats.org/officeDocument/2006/relationships" id="256" r:id="R024acb8c7742468c"/>
+    <p:sldId xmlns:r="http://schemas.openxmlformats.org/officeDocument/2006/relationships" id="257" r:id="Ra28885c529fe44e7"/>
+    <p:sldId xmlns:r="http://schemas.openxmlformats.org/officeDocument/2006/relationships" id="258" r:id="R11b7491667244101"/>
+    <p:sldId xmlns:r="http://schemas.openxmlformats.org/officeDocument/2006/relationships" id="259" r:id="Re1df061e46ea4b4b"/>
+    <p:sldId xmlns:r="http://schemas.openxmlformats.org/officeDocument/2006/relationships" id="260" r:id="R149f52029dc743a0"/>
+    <p:sldId xmlns:r="http://schemas.openxmlformats.org/officeDocument/2006/relationships" id="261" r:id="R67df11d645b940a1"/>
+    <p:sldId xmlns:r="http://schemas.openxmlformats.org/officeDocument/2006/relationships" id="262" r:id="R1dced1255fca44fa"/>
+    <p:sldId xmlns:r="http://schemas.openxmlformats.org/officeDocument/2006/relationships" id="263" r:id="Rfecc9bd275074d7d"/>
+    <p:sldId xmlns:r="http://schemas.openxmlformats.org/officeDocument/2006/relationships" id="264" r:id="Rcb54e30538134ec5"/>
+    <p:sldId xmlns:r="http://schemas.openxmlformats.org/officeDocument/2006/relationships" id="265" r:id="R21226264cc104a62"/>
+    <p:sldId xmlns:r="http://schemas.openxmlformats.org/officeDocument/2006/relationships" id="266" r:id="Rdd0666fded354aa4"/>
+    <p:sldId xmlns:r="http://schemas.openxmlformats.org/officeDocument/2006/relationships" id="267" r:id="Rb9d8279e2ca94e50"/>
+    <p:sldId xmlns:r="http://schemas.openxmlformats.org/officeDocument/2006/relationships" id="268" r:id="R1373c197737d4a48"/>
+    <p:sldId xmlns:r="http://schemas.openxmlformats.org/officeDocument/2006/relationships" id="269" r:id="R201a3fecc132470d"/>
+    <p:sldId xmlns:r="http://schemas.openxmlformats.org/officeDocument/2006/relationships" id="270" r:id="R74ece5a8e2df43c7"/>
+    <p:sldId xmlns:r="http://schemas.openxmlformats.org/officeDocument/2006/relationships" id="271" r:id="R1840a6d303164dbb"/>
   </p:sldIdLst>
   <p:sldSz cx="12192000" cy="6858000"/>
   <p:notesSz cx="6858000" cy="9144000"/>
@@ -794,7 +794,7 @@
           </a:p>
           <a:p xmlns:a="http://schemas.openxmlformats.org/drawingml/2006/main">
             <a:r>
-              <a:t>35 秒：默认 209 与独立 PG 27 分开计数；任何 official AgentTeams、GPU 或 PolarDB live 结论都不从本地测试外推。</a:t>
+              <a:t>35 秒：默认 210 与独立 PG 27 分开计数；任何 official AgentTeams、GPU 或 PolarDB live 结论都不从本地测试外推。</a:t>
             </a:r>
           </a:p>
         </p:txBody>
@@ -2114,7 +2114,7 @@
   </p:cSld>
   <p:clrMap bg1="lt1" tx1="dk1" bg2="lt2" tx2="dk2" accent1="accent1" accent2="accent2" accent3="accent3" accent4="accent4" accent5="accent5" accent6="accent6" hlink="hlink" folHlink="folHlink"/>
   <p:sldLayoutIdLst>
-    <p:sldLayoutId xmlns:r="http://schemas.openxmlformats.org/officeDocument/2006/relationships" id="2147483649" r:id="R7dcbf26137d341b3"/>
+    <p:sldLayoutId xmlns:r="http://schemas.openxmlformats.org/officeDocument/2006/relationships" id="2147483649" r:id="Rb9e9ee07fab14b68"/>
   </p:sldLayoutIdLst>
   <p:hf sldNum="0" hdr="0" ftr="0" dt="0"/>
   <p:txStyles>
@@ -2358,7 +2358,7 @@
   </p:cSld>
   <p:clrMap bg1="lt1" tx1="dk1" bg2="lt2" tx2="dk2" accent1="accent1" accent2="accent2" accent3="accent3" accent4="accent4" accent5="accent5" accent6="accent6" hlink="hlink" folHlink="folHlink"/>
   <p:sldLayoutIdLst>
-    <p:sldLayoutId xmlns:r="http://schemas.openxmlformats.org/officeDocument/2006/relationships" id="2147483651" r:id="R0f2806edff0f4a9a"/>
+    <p:sldLayoutId xmlns:r="http://schemas.openxmlformats.org/officeDocument/2006/relationships" id="2147483651" r:id="Rdd775634da844c4e"/>
   </p:sldLayoutIdLst>
   <p:hf sldNum="0" hdr="0" ftr="0" dt="0"/>
   <p:txStyles>
@@ -3476,7 +3476,7 @@
           <p:nvPr/>
         </p:nvPicPr>
         <p:blipFill>
-          <a:blip xmlns:r="http://schemas.openxmlformats.org/officeDocument/2006/relationships" xmlns:a="http://schemas.openxmlformats.org/drawingml/2006/main" r:embed="R8dd2c194b96a4080"/>
+          <a:blip xmlns:r="http://schemas.openxmlformats.org/officeDocument/2006/relationships" xmlns:a="http://schemas.openxmlformats.org/drawingml/2006/main" r:embed="R809cf16dc4784383"/>
           <a:srcRect xmlns:a="http://schemas.openxmlformats.org/drawingml/2006/main" l="2642" t="0" r="2642" b="0"/>
           <a:stretch xmlns:a="http://schemas.openxmlformats.org/drawingml/2006/main">
             <a:fillRect l="0" t="0" r="0" b="0"/>
@@ -3895,7 +3895,7 @@
           <p:nvPr/>
         </p:nvPicPr>
         <p:blipFill>
-          <a:blip xmlns:r="http://schemas.openxmlformats.org/officeDocument/2006/relationships" xmlns:a="http://schemas.openxmlformats.org/drawingml/2006/main" r:embed="R84dfc0cb39d24bce"/>
+          <a:blip xmlns:r="http://schemas.openxmlformats.org/officeDocument/2006/relationships" xmlns:a="http://schemas.openxmlformats.org/drawingml/2006/main" r:embed="R4d17a419aa5044f7"/>
           <a:srcRect xmlns:a="http://schemas.openxmlformats.org/drawingml/2006/main" l="7355" t="0" r="7355" b="0"/>
           <a:stretch xmlns:a="http://schemas.openxmlformats.org/drawingml/2006/main">
             <a:fillRect l="0" t="0" r="0" b="0"/>
@@ -3920,7 +3920,7 @@
           <p:nvPr/>
         </p:nvPicPr>
         <p:blipFill>
-          <a:blip xmlns:r="http://schemas.openxmlformats.org/officeDocument/2006/relationships" xmlns:a="http://schemas.openxmlformats.org/drawingml/2006/main" r:embed="R079f5e3955614a1d"/>
+          <a:blip xmlns:r="http://schemas.openxmlformats.org/officeDocument/2006/relationships" xmlns:a="http://schemas.openxmlformats.org/drawingml/2006/main" r:embed="Rca035c5507334108"/>
           <a:stretch xmlns:a="http://schemas.openxmlformats.org/drawingml/2006/main"/>
         </p:blipFill>
         <p:spPr>
@@ -4336,7 +4336,7 @@
           <p:nvPr/>
         </p:nvPicPr>
         <p:blipFill>
-          <a:blip xmlns:r="http://schemas.openxmlformats.org/officeDocument/2006/relationships" xmlns:a="http://schemas.openxmlformats.org/drawingml/2006/main" r:embed="Re71df22514cb43d4"/>
+          <a:blip xmlns:r="http://schemas.openxmlformats.org/officeDocument/2006/relationships" xmlns:a="http://schemas.openxmlformats.org/drawingml/2006/main" r:embed="R5cf1c480ab4e4e5b"/>
           <a:srcRect xmlns:a="http://schemas.openxmlformats.org/drawingml/2006/main" l="7355" t="0" r="7355" b="0"/>
           <a:stretch xmlns:a="http://schemas.openxmlformats.org/drawingml/2006/main">
             <a:fillRect l="0" t="0" r="0" b="0"/>
@@ -4361,7 +4361,7 @@
           <p:nvPr/>
         </p:nvPicPr>
         <p:blipFill>
-          <a:blip xmlns:r="http://schemas.openxmlformats.org/officeDocument/2006/relationships" xmlns:a="http://schemas.openxmlformats.org/drawingml/2006/main" r:embed="R7b39676bdc0a4f94"/>
+          <a:blip xmlns:r="http://schemas.openxmlformats.org/officeDocument/2006/relationships" xmlns:a="http://schemas.openxmlformats.org/drawingml/2006/main" r:embed="Re1b0b3b6d5774b52"/>
           <a:stretch xmlns:a="http://schemas.openxmlformats.org/drawingml/2006/main"/>
         </p:blipFill>
         <p:spPr>
@@ -4572,7 +4572,7 @@
                 <a:ea typeface="Noto Sans CJK SC"/>
                 <a:cs typeface="Noto Sans CJK SC"/>
               </a:rPr>
-              <a:t>默认 209 tests 全过；另有 PostgreSQL 16.14 / 27 tests。外部 live 项单列 NOT RUN。</a:t>
+              <a:t>默认 210 tests 全过；另有 PostgreSQL 16.14 / 27 tests。外部 live 项单列 NOT RUN。</a:t>
             </a:r>
             <a:endParaRPr sz="885" b="1">
               <a:solidFill>
@@ -5329,7 +5329,7 @@
                 <a:ea typeface="Noto Sans CJK SC"/>
                 <a:cs typeface="Noto Sans CJK SC"/>
               </a:rPr>
-              <a:t>209</a:t>
+              <a:t>210</a:t>
             </a:r>
             <a:endParaRPr sz="1500" b="1" i="0">
               <a:solidFill>
@@ -5719,7 +5719,7 @@
                 <a:ea typeface="Noto Sans CJK SC"/>
                 <a:cs typeface="Noto Sans CJK SC"/>
               </a:rPr>
-              <a:t>API 56 · RXP 26 · Skills 6 · Proof 1 · Benchmark 28
+              <a:t>API 56 · RXP 26 · Skills 6 · Proof 2 · Benchmark 28
 Acceptance 16 · AgentTeams 28 · Experiments 13 · MCP 23 · Web 12</a:t>
             </a:r>
             <a:endParaRPr sz="720" b="0" i="0">
@@ -21671,7 +21671,7 @@
       </p:sp>
       <p:cxnSp>
         <p:nvCxnSpPr>
-          <p:cNvPr id="204" name="直接箭头连接符 56"/>
+          <p:cNvPr id="225" name="直接箭头连接符 56"/>
           <p:cNvCxnSpPr>
             <a:stCxn xmlns:a="http://schemas.openxmlformats.org/drawingml/2006/main" id="12" idx="3"/>
             <a:endCxn xmlns:a="http://schemas.openxmlformats.org/drawingml/2006/main" id="17" idx="1"/>
@@ -21697,7 +21697,7 @@
       </p:cxnSp>
       <p:cxnSp>
         <p:nvCxnSpPr>
-          <p:cNvPr id="205" name="直接箭头连接符 57"/>
+          <p:cNvPr id="226" name="直接箭头连接符 57"/>
           <p:cNvCxnSpPr>
             <a:stCxn xmlns:a="http://schemas.openxmlformats.org/drawingml/2006/main" id="13" idx="3"/>
             <a:endCxn xmlns:a="http://schemas.openxmlformats.org/drawingml/2006/main" id="17" idx="1"/>
@@ -21723,7 +21723,7 @@
       </p:cxnSp>
       <p:cxnSp>
         <p:nvCxnSpPr>
-          <p:cNvPr id="206" name="直接箭头连接符 58"/>
+          <p:cNvPr id="227" name="直接箭头连接符 58"/>
           <p:cNvCxnSpPr>
             <a:stCxn xmlns:a="http://schemas.openxmlformats.org/drawingml/2006/main" id="14" idx="3"/>
             <a:endCxn xmlns:a="http://schemas.openxmlformats.org/drawingml/2006/main" id="17" idx="1"/>
@@ -21749,7 +21749,7 @@
       </p:cxnSp>
       <p:cxnSp>
         <p:nvCxnSpPr>
-          <p:cNvPr id="207" name="直接箭头连接符 59"/>
+          <p:cNvPr id="228" name="直接箭头连接符 59"/>
           <p:cNvCxnSpPr>
             <a:stCxn xmlns:a="http://schemas.openxmlformats.org/drawingml/2006/main" id="15" idx="3"/>
             <a:endCxn xmlns:a="http://schemas.openxmlformats.org/drawingml/2006/main" id="17" idx="1"/>
@@ -21775,7 +21775,7 @@
       </p:cxnSp>
       <p:cxnSp>
         <p:nvCxnSpPr>
-          <p:cNvPr id="208" name="直接箭头连接符 60"/>
+          <p:cNvPr id="229" name="直接箭头连接符 60"/>
           <p:cNvCxnSpPr>
             <a:stCxn xmlns:a="http://schemas.openxmlformats.org/drawingml/2006/main" id="16" idx="3"/>
             <a:endCxn xmlns:a="http://schemas.openxmlformats.org/drawingml/2006/main" id="17" idx="1"/>
@@ -21801,7 +21801,7 @@
       </p:cxnSp>
       <p:cxnSp>
         <p:nvCxnSpPr>
-          <p:cNvPr id="209" name="直接箭头连接符 61"/>
+          <p:cNvPr id="230" name="直接箭头连接符 61"/>
           <p:cNvCxnSpPr>
             <a:stCxn xmlns:a="http://schemas.openxmlformats.org/drawingml/2006/main" id="17" idx="3"/>
             <a:endCxn xmlns:a="http://schemas.openxmlformats.org/drawingml/2006/main" id="18" idx="1"/>
@@ -26232,7 +26232,7 @@
       </p:sp>
       <p:cxnSp>
         <p:nvCxnSpPr>
-          <p:cNvPr id="579" name="直接箭头连接符 158"/>
+          <p:cNvPr id="639" name="直接箭头连接符 158"/>
           <p:cNvCxnSpPr>
             <a:stCxn xmlns:a="http://schemas.openxmlformats.org/drawingml/2006/main" id="41" idx="3"/>
             <a:endCxn xmlns:a="http://schemas.openxmlformats.org/drawingml/2006/main" id="47" idx="1"/>
@@ -26258,7 +26258,7 @@
       </p:cxnSp>
       <p:cxnSp>
         <p:nvCxnSpPr>
-          <p:cNvPr id="580" name="直接箭头连接符 159"/>
+          <p:cNvPr id="640" name="直接箭头连接符 159"/>
           <p:cNvCxnSpPr>
             <a:stCxn xmlns:a="http://schemas.openxmlformats.org/drawingml/2006/main" id="42" idx="3"/>
             <a:endCxn xmlns:a="http://schemas.openxmlformats.org/drawingml/2006/main" id="47" idx="1"/>
@@ -26284,7 +26284,7 @@
       </p:cxnSp>
       <p:cxnSp>
         <p:nvCxnSpPr>
-          <p:cNvPr id="581" name="直接箭头连接符 160"/>
+          <p:cNvPr id="641" name="直接箭头连接符 160"/>
           <p:cNvCxnSpPr>
             <a:stCxn xmlns:a="http://schemas.openxmlformats.org/drawingml/2006/main" id="43" idx="3"/>
             <a:endCxn xmlns:a="http://schemas.openxmlformats.org/drawingml/2006/main" id="47" idx="1"/>
@@ -26310,7 +26310,7 @@
       </p:cxnSp>
       <p:cxnSp>
         <p:nvCxnSpPr>
-          <p:cNvPr id="582" name="直接箭头连接符 161"/>
+          <p:cNvPr id="642" name="直接箭头连接符 161"/>
           <p:cNvCxnSpPr>
             <a:stCxn xmlns:a="http://schemas.openxmlformats.org/drawingml/2006/main" id="44" idx="3"/>
             <a:endCxn xmlns:a="http://schemas.openxmlformats.org/drawingml/2006/main" id="47" idx="1"/>
@@ -26336,7 +26336,7 @@
       </p:cxnSp>
       <p:cxnSp>
         <p:nvCxnSpPr>
-          <p:cNvPr id="583" name="直接箭头连接符 162"/>
+          <p:cNvPr id="643" name="直接箭头连接符 162"/>
           <p:cNvCxnSpPr>
             <a:stCxn xmlns:a="http://schemas.openxmlformats.org/drawingml/2006/main" id="45" idx="3"/>
             <a:endCxn xmlns:a="http://schemas.openxmlformats.org/drawingml/2006/main" id="47" idx="1"/>
@@ -30205,7 +30205,7 @@
       </p:sp>
       <p:cxnSp>
         <p:nvCxnSpPr>
-          <p:cNvPr id="579" name="直接箭头连接符 158"/>
+          <p:cNvPr id="639" name="直接箭头连接符 158"/>
           <p:cNvCxnSpPr>
             <a:stCxn xmlns:a="http://schemas.openxmlformats.org/drawingml/2006/main" id="41" idx="3"/>
             <a:endCxn xmlns:a="http://schemas.openxmlformats.org/drawingml/2006/main" id="47" idx="1"/>
@@ -30231,7 +30231,7 @@
       </p:cxnSp>
       <p:cxnSp>
         <p:nvCxnSpPr>
-          <p:cNvPr id="580" name="直接箭头连接符 159"/>
+          <p:cNvPr id="640" name="直接箭头连接符 159"/>
           <p:cNvCxnSpPr>
             <a:stCxn xmlns:a="http://schemas.openxmlformats.org/drawingml/2006/main" id="42" idx="3"/>
             <a:endCxn xmlns:a="http://schemas.openxmlformats.org/drawingml/2006/main" id="47" idx="1"/>
@@ -30257,7 +30257,7 @@
       </p:cxnSp>
       <p:cxnSp>
         <p:nvCxnSpPr>
-          <p:cNvPr id="581" name="直接箭头连接符 160"/>
+          <p:cNvPr id="641" name="直接箭头连接符 160"/>
           <p:cNvCxnSpPr>
             <a:stCxn xmlns:a="http://schemas.openxmlformats.org/drawingml/2006/main" id="43" idx="3"/>
             <a:endCxn xmlns:a="http://schemas.openxmlformats.org/drawingml/2006/main" id="47" idx="1"/>
@@ -30283,7 +30283,7 @@
       </p:cxnSp>
       <p:cxnSp>
         <p:nvCxnSpPr>
-          <p:cNvPr id="582" name="直接箭头连接符 161"/>
+          <p:cNvPr id="642" name="直接箭头连接符 161"/>
           <p:cNvCxnSpPr>
             <a:stCxn xmlns:a="http://schemas.openxmlformats.org/drawingml/2006/main" id="44" idx="3"/>
             <a:endCxn xmlns:a="http://schemas.openxmlformats.org/drawingml/2006/main" id="47" idx="1"/>
@@ -30309,7 +30309,7 @@
       </p:cxnSp>
       <p:cxnSp>
         <p:nvCxnSpPr>
-          <p:cNvPr id="583" name="直接箭头连接符 162"/>
+          <p:cNvPr id="643" name="直接箭头连接符 162"/>
           <p:cNvCxnSpPr>
             <a:stCxn xmlns:a="http://schemas.openxmlformats.org/drawingml/2006/main" id="45" idx="3"/>
             <a:endCxn xmlns:a="http://schemas.openxmlformats.org/drawingml/2006/main" id="47" idx="1"/>

</xml_diff>